<commit_message>
Add WhatsApp + IA slide (45 slides) + WhatsApp tools to platform
</commit_message>
<xml_diff>
--- a/Modulo1_IA_PMEs_COMPLETO.pptx
+++ b/Modulo1_IA_PMEs_COMPLETO.pptx
@@ -34,6 +34,7 @@
     <p:sldId id="282" r:id="rId28"/>
     <p:sldId id="283" r:id="rId29"/>
     <p:sldId id="284" r:id="rId30"/>
+    <p:sldId id="300" r:id="rId51"/>
     <p:sldId id="285" r:id="rId31"/>
     <p:sldId id="286" r:id="rId32"/>
     <p:sldId id="287" r:id="rId33"/>
@@ -3963,6 +3964,125 @@
         <p14:creationId xmlns:p14="http://schemas.microsoft.com/office/powerpoint/2010/main" val="1024086991"/>
       </p:ext>
     </p:extLst>
+  </p:cSld>
+  <p:clrMapOvr>
+    <a:masterClrMapping/>
+  </p:clrMapOvr>
+</p:notes>
+</file>
+
+<file path=ppt/notesSlides/notesSlide45.xml><?xml version="1.0" encoding="utf-8"?>
+<p:notes xmlns:a="http://schemas.openxmlformats.org/drawingml/2006/main" xmlns:p="http://schemas.openxmlformats.org/presentationml/2006/main" xmlns:r="http://schemas.openxmlformats.org/officeDocument/2006/relationships">
+  <p:cSld>
+    <p:spTree>
+      <p:nvGrpSpPr>
+        <p:cNvPr id="1" name=""/>
+        <p:cNvGrpSpPr/>
+        <p:nvPr/>
+      </p:nvGrpSpPr>
+      <p:grpSpPr>
+        <a:xfrm>
+          <a:off x="0" y="0"/>
+          <a:ext cx="0" cy="0"/>
+          <a:chOff x="0" y="0"/>
+          <a:chExt cx="0" cy="0"/>
+        </a:xfrm>
+      </p:grpSpPr>
+      <p:sp>
+        <p:nvSpPr>
+          <p:cNvPr id="2" name="Slide Image Placeholder 1"/>
+          <p:cNvSpPr>
+            <a:spLocks noGrp="1"/>
+          </p:cNvSpPr>
+          <p:nvPr>
+            <p:ph type="sldImg" idx="2"/>
+          </p:nvPr>
+        </p:nvSpPr>
+        <p:spPr/>
+      </p:sp>
+      <p:sp>
+        <p:nvSpPr>
+          <p:cNvPr id="3" name="Notes Placeholder 2"/>
+          <p:cNvSpPr>
+            <a:spLocks noGrp="1"/>
+          </p:cNvSpPr>
+          <p:nvPr>
+            <p:ph type="body" idx="3" sz="quarter"/>
+          </p:nvPr>
+        </p:nvSpPr>
+        <p:spPr/>
+        <p:txBody>
+          <a:bodyPr/>
+          <a:lstStyle/>
+          <a:p>
+            <a:r>
+              <a:t>SCRIPT SLIDE BONUS - WHATSAPP + IA:</a:t>
+            </a:r>
+          </a:p>
+          <a:p>
+            <a:r>
+              <a:t>Esta e a pergunta que mais recebo: como automatizo o meu WhatsApp com IA?</a:t>
+            </a:r>
+          </a:p>
+          <a:p/>
+          <a:p>
+            <a:r>
+              <a:t>Para o nivel ANDAR (30-70 euros/mes):</a:t>
+            </a:r>
+          </a:p>
+          <a:p>
+            <a:r>
+              <a:t>- Tidio: chatbot com IA Lyro, suporta portugues, plano gratuito. Setup 30 min.</a:t>
+            </a:r>
+          </a:p>
+          <a:p>
+            <a:r>
+              <a:t>- WATI: 100% WhatsApp Business API, AI Co-pilot, inbox equipa, broadcasts.</a:t>
+            </a:r>
+          </a:p>
+          <a:p/>
+          <a:p>
+            <a:r>
+              <a:t>Para o nivel CORRER (100-200 euros/mes):</a:t>
+            </a:r>
+          </a:p>
+          <a:p>
+            <a:r>
+              <a:t>- Kommo (ex-amoCRM): CRM completo com WhatsApp integrado.</a:t>
+            </a:r>
+          </a:p>
+          <a:p>
+            <a:r>
+              <a:t>- Respond.io: multi-canal com AI Agents, 10+ canais.</a:t>
+            </a:r>
+          </a:p>
+          <a:p/>
+          <a:p>
+            <a:r>
+              <a:t>Recomendacao: Tidio gratuito esta semana &gt; WATI quando validarem &gt; Kommo/Respond.io com ROI comprovado.</a:t>
+            </a:r>
+          </a:p>
+          <a:p/>
+          <a:p>
+            <a:r>
+              <a:t>O chatbot responde as 3 da manha. A equipa dorme. O negocio nao para.</a:t>
+            </a:r>
+          </a:p>
+        </p:txBody>
+      </p:sp>
+      <p:sp>
+        <p:nvSpPr>
+          <p:cNvPr id="4" name="Slide Number Placeholder 3"/>
+          <p:cNvSpPr>
+            <a:spLocks noGrp="1"/>
+          </p:cNvSpPr>
+          <p:nvPr>
+            <p:ph type="sldNum" idx="5" sz="quarter"/>
+          </p:nvPr>
+        </p:nvSpPr>
+        <p:spPr/>
+      </p:sp>
+    </p:spTree>
   </p:cSld>
   <p:clrMapOvr>
     <a:masterClrMapping/>
@@ -37951,6 +38071,1389 @@
 </p:sld>
 </file>
 
+<file path=ppt/slides/slide45.xml><?xml version="1.0" encoding="utf-8"?>
+<p:sld xmlns:a="http://schemas.openxmlformats.org/drawingml/2006/main" xmlns:p="http://schemas.openxmlformats.org/presentationml/2006/main" xmlns:r="http://schemas.openxmlformats.org/officeDocument/2006/relationships">
+  <p:cSld>
+    <p:bg>
+      <p:bgPr>
+        <a:solidFill>
+          <a:srgbClr val="F7F8FA"/>
+        </a:solidFill>
+        <a:effectLst/>
+      </p:bgPr>
+    </p:bg>
+    <p:spTree>
+      <p:nvGrpSpPr>
+        <p:cNvPr id="1" name=""/>
+        <p:cNvGrpSpPr/>
+        <p:nvPr/>
+      </p:nvGrpSpPr>
+      <p:grpSpPr/>
+      <p:sp>
+        <p:nvSpPr>
+          <p:cNvPr id="2" name="Rectangle 1"/>
+          <p:cNvSpPr/>
+          <p:nvPr/>
+        </p:nvSpPr>
+        <p:spPr>
+          <a:xfrm>
+            <a:off x="0" y="0"/>
+            <a:ext cx="9144000" cy="54864"/>
+          </a:xfrm>
+          <a:prstGeom prst="rect">
+            <a:avLst/>
+          </a:prstGeom>
+          <a:solidFill>
+            <a:srgbClr val="E87722"/>
+          </a:solidFill>
+          <a:ln>
+            <a:noFill/>
+          </a:ln>
+        </p:spPr>
+        <p:style>
+          <a:lnRef idx="1">
+            <a:schemeClr val="accent1"/>
+          </a:lnRef>
+          <a:fillRef idx="3">
+            <a:schemeClr val="accent1"/>
+          </a:fillRef>
+          <a:effectRef idx="2">
+            <a:schemeClr val="accent1"/>
+          </a:effectRef>
+          <a:fontRef idx="minor">
+            <a:schemeClr val="lt1"/>
+          </a:fontRef>
+        </p:style>
+        <p:txBody>
+          <a:bodyPr rtlCol="0" anchor="ctr"/>
+          <a:lstStyle/>
+          <a:p>
+            <a:pPr algn="ctr"/>
+          </a:p>
+        </p:txBody>
+      </p:sp>
+      <p:sp>
+        <p:nvSpPr>
+          <p:cNvPr id="3" name="Rectangle 2"/>
+          <p:cNvSpPr/>
+          <p:nvPr/>
+        </p:nvSpPr>
+        <p:spPr>
+          <a:xfrm>
+            <a:off x="8229600" y="137160"/>
+            <a:ext cx="640080" cy="320040"/>
+          </a:xfrm>
+          <a:prstGeom prst="rect">
+            <a:avLst/>
+          </a:prstGeom>
+          <a:solidFill>
+            <a:srgbClr val="E87722"/>
+          </a:solidFill>
+          <a:ln>
+            <a:noFill/>
+          </a:ln>
+        </p:spPr>
+        <p:style>
+          <a:lnRef idx="1">
+            <a:schemeClr val="accent1"/>
+          </a:lnRef>
+          <a:fillRef idx="3">
+            <a:schemeClr val="accent1"/>
+          </a:fillRef>
+          <a:effectRef idx="2">
+            <a:schemeClr val="accent1"/>
+          </a:effectRef>
+          <a:fontRef idx="minor">
+            <a:schemeClr val="lt1"/>
+          </a:fontRef>
+        </p:style>
+        <p:txBody>
+          <a:bodyPr rtlCol="0" anchor="ctr"/>
+          <a:lstStyle/>
+          <a:p>
+            <a:pPr algn="ctr"/>
+            <a:r>
+              <a:rPr sz="1100" b="1">
+                <a:solidFill>
+                  <a:srgbClr val="FFFFFF"/>
+                </a:solidFill>
+                <a:latin typeface="Calibri"/>
+              </a:rPr>
+              <a:t>BONUS</a:t>
+            </a:r>
+          </a:p>
+        </p:txBody>
+      </p:sp>
+      <p:sp>
+        <p:nvSpPr>
+          <p:cNvPr id="4" name="TextBox 3"/>
+          <p:cNvSpPr txBox="1"/>
+          <p:nvPr/>
+        </p:nvSpPr>
+        <p:spPr>
+          <a:xfrm>
+            <a:off x="457200" y="228600"/>
+            <a:ext cx="7772400" cy="548640"/>
+          </a:xfrm>
+          <a:prstGeom prst="rect">
+            <a:avLst/>
+          </a:prstGeom>
+          <a:noFill/>
+        </p:spPr>
+        <p:txBody>
+          <a:bodyPr wrap="none">
+            <a:spAutoFit/>
+          </a:bodyPr>
+          <a:lstStyle/>
+          <a:p>
+            <a:r>
+              <a:rPr sz="2600" b="1">
+                <a:solidFill>
+                  <a:srgbClr val="1B365D"/>
+                </a:solidFill>
+                <a:latin typeface="Georgia"/>
+              </a:rPr>
+              <a:t>WhatsApp + IA: Como Automatizar</a:t>
+            </a:r>
+          </a:p>
+        </p:txBody>
+      </p:sp>
+      <p:sp>
+        <p:nvSpPr>
+          <p:cNvPr id="5" name="TextBox 4"/>
+          <p:cNvSpPr txBox="1"/>
+          <p:nvPr/>
+        </p:nvSpPr>
+        <p:spPr>
+          <a:xfrm>
+            <a:off x="457200" y="777240"/>
+            <a:ext cx="7772400" cy="365760"/>
+          </a:xfrm>
+          <a:prstGeom prst="rect">
+            <a:avLst/>
+          </a:prstGeom>
+          <a:noFill/>
+        </p:spPr>
+        <p:txBody>
+          <a:bodyPr wrap="none">
+            <a:spAutoFit/>
+          </a:bodyPr>
+          <a:lstStyle/>
+          <a:p>
+            <a:r>
+              <a:rPr sz="1300">
+                <a:solidFill>
+                  <a:srgbClr val="0891B2"/>
+                </a:solidFill>
+                <a:latin typeface="Calibri"/>
+              </a:rPr>
+              <a:t>Do atendimento manual ao chatbot inteligente - ferramentas reais para PMEs</a:t>
+            </a:r>
+          </a:p>
+        </p:txBody>
+      </p:sp>
+      <p:sp>
+        <p:nvSpPr>
+          <p:cNvPr id="6" name="Rectangle 5"/>
+          <p:cNvSpPr/>
+          <p:nvPr/>
+        </p:nvSpPr>
+        <p:spPr>
+          <a:xfrm>
+            <a:off x="365760" y="1371600"/>
+            <a:ext cx="4023360" cy="1463040"/>
+          </a:xfrm>
+          <a:prstGeom prst="rect">
+            <a:avLst/>
+          </a:prstGeom>
+          <a:solidFill>
+            <a:srgbClr val="FFFFFF"/>
+          </a:solidFill>
+          <a:ln>
+            <a:noFill/>
+          </a:ln>
+        </p:spPr>
+        <p:style>
+          <a:lnRef idx="1">
+            <a:schemeClr val="accent1"/>
+          </a:lnRef>
+          <a:fillRef idx="3">
+            <a:schemeClr val="accent1"/>
+          </a:fillRef>
+          <a:effectRef idx="2">
+            <a:schemeClr val="accent1"/>
+          </a:effectRef>
+          <a:fontRef idx="minor">
+            <a:schemeClr val="lt1"/>
+          </a:fontRef>
+        </p:style>
+        <p:txBody>
+          <a:bodyPr rtlCol="0" anchor="ctr"/>
+          <a:lstStyle/>
+          <a:p>
+            <a:pPr algn="ctr"/>
+          </a:p>
+        </p:txBody>
+      </p:sp>
+      <p:sp>
+        <p:nvSpPr>
+          <p:cNvPr id="7" name="TextBox 6"/>
+          <p:cNvSpPr txBox="1"/>
+          <p:nvPr/>
+        </p:nvSpPr>
+        <p:spPr>
+          <a:xfrm>
+            <a:off x="548640" y="1417320"/>
+            <a:ext cx="3657600" cy="274320"/>
+          </a:xfrm>
+          <a:prstGeom prst="rect">
+            <a:avLst/>
+          </a:prstGeom>
+          <a:noFill/>
+        </p:spPr>
+        <p:txBody>
+          <a:bodyPr wrap="none">
+            <a:spAutoFit/>
+          </a:bodyPr>
+          <a:lstStyle/>
+          <a:p>
+            <a:r>
+              <a:rPr sz="1300" b="1">
+                <a:solidFill>
+                  <a:srgbClr val="EB5757"/>
+                </a:solidFill>
+                <a:latin typeface="Calibri"/>
+              </a:rPr>
+              <a:t>O Problema (sem automacao)</a:t>
+            </a:r>
+          </a:p>
+        </p:txBody>
+      </p:sp>
+      <p:sp>
+        <p:nvSpPr>
+          <p:cNvPr id="8" name="TextBox 7"/>
+          <p:cNvSpPr txBox="1"/>
+          <p:nvPr/>
+        </p:nvSpPr>
+        <p:spPr>
+          <a:xfrm>
+            <a:off x="640080" y="1755648"/>
+            <a:ext cx="3566160" cy="237744"/>
+          </a:xfrm>
+          <a:prstGeom prst="rect">
+            <a:avLst/>
+          </a:prstGeom>
+          <a:noFill/>
+        </p:spPr>
+        <p:txBody>
+          <a:bodyPr wrap="none">
+            <a:spAutoFit/>
+          </a:bodyPr>
+          <a:lstStyle/>
+          <a:p>
+            <a:r>
+              <a:rPr sz="1050">
+                <a:solidFill>
+                  <a:srgbClr val="2D3A4A"/>
+                </a:solidFill>
+                <a:latin typeface="Calibri"/>
+              </a:rPr>
+              <a:t>x  Responder manualmente 50-200 msgs/dia</a:t>
+            </a:r>
+          </a:p>
+        </p:txBody>
+      </p:sp>
+      <p:sp>
+        <p:nvSpPr>
+          <p:cNvPr id="9" name="TextBox 8"/>
+          <p:cNvSpPr txBox="1"/>
+          <p:nvPr/>
+        </p:nvSpPr>
+        <p:spPr>
+          <a:xfrm>
+            <a:off x="640080" y="2011680"/>
+            <a:ext cx="3566160" cy="237744"/>
+          </a:xfrm>
+          <a:prstGeom prst="rect">
+            <a:avLst/>
+          </a:prstGeom>
+          <a:noFill/>
+        </p:spPr>
+        <p:txBody>
+          <a:bodyPr wrap="none">
+            <a:spAutoFit/>
+          </a:bodyPr>
+          <a:lstStyle/>
+          <a:p>
+            <a:r>
+              <a:rPr sz="1050">
+                <a:solidFill>
+                  <a:srgbClr val="2D3A4A"/>
+                </a:solidFill>
+                <a:latin typeface="Calibri"/>
+              </a:rPr>
+              <a:t>x  Copiar dados WhatsApp para CRM/ERP</a:t>
+            </a:r>
+          </a:p>
+        </p:txBody>
+      </p:sp>
+      <p:sp>
+        <p:nvSpPr>
+          <p:cNvPr id="10" name="TextBox 9"/>
+          <p:cNvSpPr txBox="1"/>
+          <p:nvPr/>
+        </p:nvSpPr>
+        <p:spPr>
+          <a:xfrm>
+            <a:off x="640080" y="2267712"/>
+            <a:ext cx="3566160" cy="237744"/>
+          </a:xfrm>
+          <a:prstGeom prst="rect">
+            <a:avLst/>
+          </a:prstGeom>
+          <a:noFill/>
+        </p:spPr>
+        <p:txBody>
+          <a:bodyPr wrap="none">
+            <a:spAutoFit/>
+          </a:bodyPr>
+          <a:lstStyle/>
+          <a:p>
+            <a:r>
+              <a:rPr sz="1050">
+                <a:solidFill>
+                  <a:srgbClr val="2D3A4A"/>
+                </a:solidFill>
+                <a:latin typeface="Calibri"/>
+              </a:rPr>
+              <a:t>x  FAQs repetitivas = 60% do volume</a:t>
+            </a:r>
+          </a:p>
+        </p:txBody>
+      </p:sp>
+      <p:sp>
+        <p:nvSpPr>
+          <p:cNvPr id="11" name="TextBox 10"/>
+          <p:cNvSpPr txBox="1"/>
+          <p:nvPr/>
+        </p:nvSpPr>
+        <p:spPr>
+          <a:xfrm>
+            <a:off x="640080" y="2523744"/>
+            <a:ext cx="3566160" cy="237744"/>
+          </a:xfrm>
+          <a:prstGeom prst="rect">
+            <a:avLst/>
+          </a:prstGeom>
+          <a:noFill/>
+        </p:spPr>
+        <p:txBody>
+          <a:bodyPr wrap="none">
+            <a:spAutoFit/>
+          </a:bodyPr>
+          <a:lstStyle/>
+          <a:p>
+            <a:r>
+              <a:rPr sz="1050">
+                <a:solidFill>
+                  <a:srgbClr val="2D3A4A"/>
+                </a:solidFill>
+                <a:latin typeface="Calibri"/>
+              </a:rPr>
+              <a:t>x  Sem resposta fora horario = clientes perdidos</a:t>
+            </a:r>
+          </a:p>
+        </p:txBody>
+      </p:sp>
+      <p:sp>
+        <p:nvSpPr>
+          <p:cNvPr id="12" name="Rectangle 11"/>
+          <p:cNvSpPr/>
+          <p:nvPr/>
+        </p:nvSpPr>
+        <p:spPr>
+          <a:xfrm>
+            <a:off x="4754880" y="1371600"/>
+            <a:ext cx="4023360" cy="1463040"/>
+          </a:xfrm>
+          <a:prstGeom prst="rect">
+            <a:avLst/>
+          </a:prstGeom>
+          <a:solidFill>
+            <a:srgbClr val="FFFFFF"/>
+          </a:solidFill>
+          <a:ln>
+            <a:noFill/>
+          </a:ln>
+        </p:spPr>
+        <p:style>
+          <a:lnRef idx="1">
+            <a:schemeClr val="accent1"/>
+          </a:lnRef>
+          <a:fillRef idx="3">
+            <a:schemeClr val="accent1"/>
+          </a:fillRef>
+          <a:effectRef idx="2">
+            <a:schemeClr val="accent1"/>
+          </a:effectRef>
+          <a:fontRef idx="minor">
+            <a:schemeClr val="lt1"/>
+          </a:fontRef>
+        </p:style>
+        <p:txBody>
+          <a:bodyPr rtlCol="0" anchor="ctr"/>
+          <a:lstStyle/>
+          <a:p>
+            <a:pPr algn="ctr"/>
+          </a:p>
+        </p:txBody>
+      </p:sp>
+      <p:sp>
+        <p:nvSpPr>
+          <p:cNvPr id="13" name="TextBox 12"/>
+          <p:cNvSpPr txBox="1"/>
+          <p:nvPr/>
+        </p:nvSpPr>
+        <p:spPr>
+          <a:xfrm>
+            <a:off x="4937760" y="1417320"/>
+            <a:ext cx="3657600" cy="274320"/>
+          </a:xfrm>
+          <a:prstGeom prst="rect">
+            <a:avLst/>
+          </a:prstGeom>
+          <a:noFill/>
+        </p:spPr>
+        <p:txBody>
+          <a:bodyPr wrap="none">
+            <a:spAutoFit/>
+          </a:bodyPr>
+          <a:lstStyle/>
+          <a:p>
+            <a:r>
+              <a:rPr sz="1300" b="1">
+                <a:solidFill>
+                  <a:srgbClr val="27AE60"/>
+                </a:solidFill>
+                <a:latin typeface="Calibri"/>
+              </a:rPr>
+              <a:t>A Solucao (com IA no WhatsApp)</a:t>
+            </a:r>
+          </a:p>
+        </p:txBody>
+      </p:sp>
+      <p:sp>
+        <p:nvSpPr>
+          <p:cNvPr id="14" name="TextBox 13"/>
+          <p:cNvSpPr txBox="1"/>
+          <p:nvPr/>
+        </p:nvSpPr>
+        <p:spPr>
+          <a:xfrm>
+            <a:off x="5029200" y="1755648"/>
+            <a:ext cx="3566160" cy="237744"/>
+          </a:xfrm>
+          <a:prstGeom prst="rect">
+            <a:avLst/>
+          </a:prstGeom>
+          <a:noFill/>
+        </p:spPr>
+        <p:txBody>
+          <a:bodyPr wrap="none">
+            <a:spAutoFit/>
+          </a:bodyPr>
+          <a:lstStyle/>
+          <a:p>
+            <a:r>
+              <a:rPr sz="1050">
+                <a:solidFill>
+                  <a:srgbClr val="2D3A4A"/>
+                </a:solidFill>
+                <a:latin typeface="Calibri"/>
+              </a:rPr>
+              <a:t>v  Chatbot responde FAQs 24/7 em segundos</a:t>
+            </a:r>
+          </a:p>
+        </p:txBody>
+      </p:sp>
+      <p:sp>
+        <p:nvSpPr>
+          <p:cNvPr id="15" name="TextBox 14"/>
+          <p:cNvSpPr txBox="1"/>
+          <p:nvPr/>
+        </p:nvSpPr>
+        <p:spPr>
+          <a:xfrm>
+            <a:off x="5029200" y="2011680"/>
+            <a:ext cx="3566160" cy="237744"/>
+          </a:xfrm>
+          <a:prstGeom prst="rect">
+            <a:avLst/>
+          </a:prstGeom>
+          <a:noFill/>
+        </p:spPr>
+        <p:txBody>
+          <a:bodyPr wrap="none">
+            <a:spAutoFit/>
+          </a:bodyPr>
+          <a:lstStyle/>
+          <a:p>
+            <a:r>
+              <a:rPr sz="1050">
+                <a:solidFill>
+                  <a:srgbClr val="2D3A4A"/>
+                </a:solidFill>
+                <a:latin typeface="Calibri"/>
+              </a:rPr>
+              <a:t>v  IA extrai dados e envia para ERP/CRM</a:t>
+            </a:r>
+          </a:p>
+        </p:txBody>
+      </p:sp>
+      <p:sp>
+        <p:nvSpPr>
+          <p:cNvPr id="16" name="TextBox 15"/>
+          <p:cNvSpPr txBox="1"/>
+          <p:nvPr/>
+        </p:nvSpPr>
+        <p:spPr>
+          <a:xfrm>
+            <a:off x="5029200" y="2267712"/>
+            <a:ext cx="3566160" cy="237744"/>
+          </a:xfrm>
+          <a:prstGeom prst="rect">
+            <a:avLst/>
+          </a:prstGeom>
+          <a:noFill/>
+        </p:spPr>
+        <p:txBody>
+          <a:bodyPr wrap="none">
+            <a:spAutoFit/>
+          </a:bodyPr>
+          <a:lstStyle/>
+          <a:p>
+            <a:r>
+              <a:rPr sz="1050">
+                <a:solidFill>
+                  <a:srgbClr val="2D3A4A"/>
+                </a:solidFill>
+                <a:latin typeface="Calibri"/>
+              </a:rPr>
+              <a:t>v  Atendimento multilingue automatico</a:t>
+            </a:r>
+          </a:p>
+        </p:txBody>
+      </p:sp>
+      <p:sp>
+        <p:nvSpPr>
+          <p:cNvPr id="17" name="TextBox 16"/>
+          <p:cNvSpPr txBox="1"/>
+          <p:nvPr/>
+        </p:nvSpPr>
+        <p:spPr>
+          <a:xfrm>
+            <a:off x="5029200" y="2523744"/>
+            <a:ext cx="3566160" cy="237744"/>
+          </a:xfrm>
+          <a:prstGeom prst="rect">
+            <a:avLst/>
+          </a:prstGeom>
+          <a:noFill/>
+        </p:spPr>
+        <p:txBody>
+          <a:bodyPr wrap="none">
+            <a:spAutoFit/>
+          </a:bodyPr>
+          <a:lstStyle/>
+          <a:p>
+            <a:r>
+              <a:rPr sz="1050">
+                <a:solidFill>
+                  <a:srgbClr val="2D3A4A"/>
+                </a:solidFill>
+                <a:latin typeface="Calibri"/>
+              </a:rPr>
+              <a:t>v  Escala 50 a 5.000 msgs sem mais staff</a:t>
+            </a:r>
+          </a:p>
+        </p:txBody>
+      </p:sp>
+      <p:sp>
+        <p:nvSpPr>
+          <p:cNvPr id="18" name="TextBox 17"/>
+          <p:cNvSpPr txBox="1"/>
+          <p:nvPr/>
+        </p:nvSpPr>
+        <p:spPr>
+          <a:xfrm>
+            <a:off x="457200" y="3017520"/>
+            <a:ext cx="8229600" cy="320040"/>
+          </a:xfrm>
+          <a:prstGeom prst="rect">
+            <a:avLst/>
+          </a:prstGeom>
+          <a:noFill/>
+        </p:spPr>
+        <p:txBody>
+          <a:bodyPr wrap="none">
+            <a:spAutoFit/>
+          </a:bodyPr>
+          <a:lstStyle/>
+          <a:p>
+            <a:r>
+              <a:rPr sz="1500" b="1">
+                <a:solidFill>
+                  <a:srgbClr val="1B365D"/>
+                </a:solidFill>
+                <a:latin typeface="Georgia"/>
+              </a:rPr>
+              <a:t>Ferramentas Recomendadas por Estagio</a:t>
+            </a:r>
+          </a:p>
+        </p:txBody>
+      </p:sp>
+      <p:sp>
+        <p:nvSpPr>
+          <p:cNvPr id="19" name="Rectangle 18"/>
+          <p:cNvSpPr/>
+          <p:nvPr/>
+        </p:nvSpPr>
+        <p:spPr>
+          <a:xfrm>
+            <a:off x="365760" y="3429000"/>
+            <a:ext cx="2011680" cy="1417320"/>
+          </a:xfrm>
+          <a:prstGeom prst="rect">
+            <a:avLst/>
+          </a:prstGeom>
+          <a:solidFill>
+            <a:srgbClr val="FFFFFF"/>
+          </a:solidFill>
+          <a:ln>
+            <a:noFill/>
+          </a:ln>
+        </p:spPr>
+        <p:style>
+          <a:lnRef idx="1">
+            <a:schemeClr val="accent1"/>
+          </a:lnRef>
+          <a:fillRef idx="3">
+            <a:schemeClr val="accent1"/>
+          </a:fillRef>
+          <a:effectRef idx="2">
+            <a:schemeClr val="accent1"/>
+          </a:effectRef>
+          <a:fontRef idx="minor">
+            <a:schemeClr val="lt1"/>
+          </a:fontRef>
+        </p:style>
+        <p:txBody>
+          <a:bodyPr rtlCol="0" anchor="ctr"/>
+          <a:lstStyle/>
+          <a:p>
+            <a:pPr algn="ctr"/>
+          </a:p>
+        </p:txBody>
+      </p:sp>
+      <p:sp>
+        <p:nvSpPr>
+          <p:cNvPr id="20" name="Rectangle 19"/>
+          <p:cNvSpPr/>
+          <p:nvPr/>
+        </p:nvSpPr>
+        <p:spPr>
+          <a:xfrm>
+            <a:off x="365760" y="3429000"/>
+            <a:ext cx="2011680" cy="256032"/>
+          </a:xfrm>
+          <a:prstGeom prst="rect">
+            <a:avLst/>
+          </a:prstGeom>
+          <a:solidFill>
+            <a:srgbClr val="0891B2"/>
+          </a:solidFill>
+          <a:ln>
+            <a:noFill/>
+          </a:ln>
+        </p:spPr>
+        <p:style>
+          <a:lnRef idx="1">
+            <a:schemeClr val="accent1"/>
+          </a:lnRef>
+          <a:fillRef idx="3">
+            <a:schemeClr val="accent1"/>
+          </a:fillRef>
+          <a:effectRef idx="2">
+            <a:schemeClr val="accent1"/>
+          </a:effectRef>
+          <a:fontRef idx="minor">
+            <a:schemeClr val="lt1"/>
+          </a:fontRef>
+        </p:style>
+        <p:txBody>
+          <a:bodyPr rtlCol="0" anchor="ctr"/>
+          <a:lstStyle/>
+          <a:p>
+            <a:pPr algn="ctr"/>
+            <a:r>
+              <a:rPr sz="900" b="1">
+                <a:solidFill>
+                  <a:srgbClr val="FFFFFF"/>
+                </a:solidFill>
+                <a:latin typeface="Calibri"/>
+              </a:rPr>
+              <a:t>ANDAR | E29-69/mes</a:t>
+            </a:r>
+          </a:p>
+        </p:txBody>
+      </p:sp>
+      <p:sp>
+        <p:nvSpPr>
+          <p:cNvPr id="21" name="TextBox 20"/>
+          <p:cNvSpPr txBox="1"/>
+          <p:nvPr/>
+        </p:nvSpPr>
+        <p:spPr>
+          <a:xfrm>
+            <a:off x="457200" y="3730752"/>
+            <a:ext cx="1828800" cy="274320"/>
+          </a:xfrm>
+          <a:prstGeom prst="rect">
+            <a:avLst/>
+          </a:prstGeom>
+          <a:noFill/>
+        </p:spPr>
+        <p:txBody>
+          <a:bodyPr wrap="none">
+            <a:spAutoFit/>
+          </a:bodyPr>
+          <a:lstStyle/>
+          <a:p>
+            <a:r>
+              <a:rPr sz="1400" b="1">
+                <a:solidFill>
+                  <a:srgbClr val="1B365D"/>
+                </a:solidFill>
+                <a:latin typeface="Calibri"/>
+              </a:rPr>
+              <a:t>Tidio</a:t>
+            </a:r>
+          </a:p>
+        </p:txBody>
+      </p:sp>
+      <p:sp>
+        <p:nvSpPr>
+          <p:cNvPr id="22" name="TextBox 21"/>
+          <p:cNvSpPr txBox="1"/>
+          <p:nvPr/>
+        </p:nvSpPr>
+        <p:spPr>
+          <a:xfrm>
+            <a:off x="457200" y="3977639"/>
+            <a:ext cx="1828800" cy="822960"/>
+          </a:xfrm>
+          <a:prstGeom prst="rect">
+            <a:avLst/>
+          </a:prstGeom>
+          <a:noFill/>
+        </p:spPr>
+        <p:txBody>
+          <a:bodyPr wrap="square">
+            <a:spAutoFit/>
+          </a:bodyPr>
+          <a:lstStyle/>
+          <a:p>
+            <a:r>
+              <a:rPr sz="950">
+                <a:solidFill>
+                  <a:srgbClr val="2D3A4A"/>
+                </a:solidFill>
+                <a:latin typeface="Calibri"/>
+              </a:rPr>
+              <a:t>Chatbot IA (Lyro) + WhatsApp
+Suporta PT | Free tier | 30 min</a:t>
+            </a:r>
+          </a:p>
+        </p:txBody>
+      </p:sp>
+      <p:sp>
+        <p:nvSpPr>
+          <p:cNvPr id="23" name="Rectangle 22"/>
+          <p:cNvSpPr/>
+          <p:nvPr/>
+        </p:nvSpPr>
+        <p:spPr>
+          <a:xfrm>
+            <a:off x="2560320" y="3429000"/>
+            <a:ext cx="2011680" cy="1417320"/>
+          </a:xfrm>
+          <a:prstGeom prst="rect">
+            <a:avLst/>
+          </a:prstGeom>
+          <a:solidFill>
+            <a:srgbClr val="FFFFFF"/>
+          </a:solidFill>
+          <a:ln>
+            <a:noFill/>
+          </a:ln>
+        </p:spPr>
+        <p:style>
+          <a:lnRef idx="1">
+            <a:schemeClr val="accent1"/>
+          </a:lnRef>
+          <a:fillRef idx="3">
+            <a:schemeClr val="accent1"/>
+          </a:fillRef>
+          <a:effectRef idx="2">
+            <a:schemeClr val="accent1"/>
+          </a:effectRef>
+          <a:fontRef idx="minor">
+            <a:schemeClr val="lt1"/>
+          </a:fontRef>
+        </p:style>
+        <p:txBody>
+          <a:bodyPr rtlCol="0" anchor="ctr"/>
+          <a:lstStyle/>
+          <a:p>
+            <a:pPr algn="ctr"/>
+          </a:p>
+        </p:txBody>
+      </p:sp>
+      <p:sp>
+        <p:nvSpPr>
+          <p:cNvPr id="24" name="Rectangle 23"/>
+          <p:cNvSpPr/>
+          <p:nvPr/>
+        </p:nvSpPr>
+        <p:spPr>
+          <a:xfrm>
+            <a:off x="2560320" y="3429000"/>
+            <a:ext cx="2011680" cy="256032"/>
+          </a:xfrm>
+          <a:prstGeom prst="rect">
+            <a:avLst/>
+          </a:prstGeom>
+          <a:solidFill>
+            <a:srgbClr val="0891B2"/>
+          </a:solidFill>
+          <a:ln>
+            <a:noFill/>
+          </a:ln>
+        </p:spPr>
+        <p:style>
+          <a:lnRef idx="1">
+            <a:schemeClr val="accent1"/>
+          </a:lnRef>
+          <a:fillRef idx="3">
+            <a:schemeClr val="accent1"/>
+          </a:fillRef>
+          <a:effectRef idx="2">
+            <a:schemeClr val="accent1"/>
+          </a:effectRef>
+          <a:fontRef idx="minor">
+            <a:schemeClr val="lt1"/>
+          </a:fontRef>
+        </p:style>
+        <p:txBody>
+          <a:bodyPr rtlCol="0" anchor="ctr"/>
+          <a:lstStyle/>
+          <a:p>
+            <a:pPr algn="ctr"/>
+            <a:r>
+              <a:rPr sz="900" b="1">
+                <a:solidFill>
+                  <a:srgbClr val="FFFFFF"/>
+                </a:solidFill>
+                <a:latin typeface="Calibri"/>
+              </a:rPr>
+              <a:t>ANDAR | $59/mes</a:t>
+            </a:r>
+          </a:p>
+        </p:txBody>
+      </p:sp>
+      <p:sp>
+        <p:nvSpPr>
+          <p:cNvPr id="25" name="TextBox 24"/>
+          <p:cNvSpPr txBox="1"/>
+          <p:nvPr/>
+        </p:nvSpPr>
+        <p:spPr>
+          <a:xfrm>
+            <a:off x="2651760" y="3730752"/>
+            <a:ext cx="1828800" cy="274320"/>
+          </a:xfrm>
+          <a:prstGeom prst="rect">
+            <a:avLst/>
+          </a:prstGeom>
+          <a:noFill/>
+        </p:spPr>
+        <p:txBody>
+          <a:bodyPr wrap="none">
+            <a:spAutoFit/>
+          </a:bodyPr>
+          <a:lstStyle/>
+          <a:p>
+            <a:r>
+              <a:rPr sz="1400" b="1">
+                <a:solidFill>
+                  <a:srgbClr val="1B365D"/>
+                </a:solidFill>
+                <a:latin typeface="Calibri"/>
+              </a:rPr>
+              <a:t>WATI</a:t>
+            </a:r>
+          </a:p>
+        </p:txBody>
+      </p:sp>
+      <p:sp>
+        <p:nvSpPr>
+          <p:cNvPr id="26" name="TextBox 25"/>
+          <p:cNvSpPr txBox="1"/>
+          <p:nvPr/>
+        </p:nvSpPr>
+        <p:spPr>
+          <a:xfrm>
+            <a:off x="2651760" y="3977639"/>
+            <a:ext cx="1828800" cy="822960"/>
+          </a:xfrm>
+          <a:prstGeom prst="rect">
+            <a:avLst/>
+          </a:prstGeom>
+          <a:noFill/>
+        </p:spPr>
+        <p:txBody>
+          <a:bodyPr wrap="square">
+            <a:spAutoFit/>
+          </a:bodyPr>
+          <a:lstStyle/>
+          <a:p>
+            <a:r>
+              <a:rPr sz="950">
+                <a:solidFill>
+                  <a:srgbClr val="2D3A4A"/>
+                </a:solidFill>
+                <a:latin typeface="Calibri"/>
+              </a:rPr>
+              <a:t>100% WhatsApp Business API
+AI Co-pilot | Inbox equipa</a:t>
+            </a:r>
+          </a:p>
+        </p:txBody>
+      </p:sp>
+      <p:sp>
+        <p:nvSpPr>
+          <p:cNvPr id="27" name="Rectangle 26"/>
+          <p:cNvSpPr/>
+          <p:nvPr/>
+        </p:nvSpPr>
+        <p:spPr>
+          <a:xfrm>
+            <a:off x="4754880" y="3429000"/>
+            <a:ext cx="2011680" cy="1417320"/>
+          </a:xfrm>
+          <a:prstGeom prst="rect">
+            <a:avLst/>
+          </a:prstGeom>
+          <a:solidFill>
+            <a:srgbClr val="FFFFFF"/>
+          </a:solidFill>
+          <a:ln>
+            <a:noFill/>
+          </a:ln>
+        </p:spPr>
+        <p:style>
+          <a:lnRef idx="1">
+            <a:schemeClr val="accent1"/>
+          </a:lnRef>
+          <a:fillRef idx="3">
+            <a:schemeClr val="accent1"/>
+          </a:fillRef>
+          <a:effectRef idx="2">
+            <a:schemeClr val="accent1"/>
+          </a:effectRef>
+          <a:fontRef idx="minor">
+            <a:schemeClr val="lt1"/>
+          </a:fontRef>
+        </p:style>
+        <p:txBody>
+          <a:bodyPr rtlCol="0" anchor="ctr"/>
+          <a:lstStyle/>
+          <a:p>
+            <a:pPr algn="ctr"/>
+          </a:p>
+        </p:txBody>
+      </p:sp>
+      <p:sp>
+        <p:nvSpPr>
+          <p:cNvPr id="28" name="Rectangle 27"/>
+          <p:cNvSpPr/>
+          <p:nvPr/>
+        </p:nvSpPr>
+        <p:spPr>
+          <a:xfrm>
+            <a:off x="4754880" y="3429000"/>
+            <a:ext cx="2011680" cy="256032"/>
+          </a:xfrm>
+          <a:prstGeom prst="rect">
+            <a:avLst/>
+          </a:prstGeom>
+          <a:solidFill>
+            <a:srgbClr val="E87722"/>
+          </a:solidFill>
+          <a:ln>
+            <a:noFill/>
+          </a:ln>
+        </p:spPr>
+        <p:style>
+          <a:lnRef idx="1">
+            <a:schemeClr val="accent1"/>
+          </a:lnRef>
+          <a:fillRef idx="3">
+            <a:schemeClr val="accent1"/>
+          </a:fillRef>
+          <a:effectRef idx="2">
+            <a:schemeClr val="accent1"/>
+          </a:effectRef>
+          <a:fontRef idx="minor">
+            <a:schemeClr val="lt1"/>
+          </a:fontRef>
+        </p:style>
+        <p:txBody>
+          <a:bodyPr rtlCol="0" anchor="ctr"/>
+          <a:lstStyle/>
+          <a:p>
+            <a:pPr algn="ctr"/>
+            <a:r>
+              <a:rPr sz="900" b="1">
+                <a:solidFill>
+                  <a:srgbClr val="FFFFFF"/>
+                </a:solidFill>
+                <a:latin typeface="Calibri"/>
+              </a:rPr>
+              <a:t>CORRER | $12.50/user</a:t>
+            </a:r>
+          </a:p>
+        </p:txBody>
+      </p:sp>
+      <p:sp>
+        <p:nvSpPr>
+          <p:cNvPr id="29" name="TextBox 28"/>
+          <p:cNvSpPr txBox="1"/>
+          <p:nvPr/>
+        </p:nvSpPr>
+        <p:spPr>
+          <a:xfrm>
+            <a:off x="4846320" y="3730752"/>
+            <a:ext cx="1828800" cy="274320"/>
+          </a:xfrm>
+          <a:prstGeom prst="rect">
+            <a:avLst/>
+          </a:prstGeom>
+          <a:noFill/>
+        </p:spPr>
+        <p:txBody>
+          <a:bodyPr wrap="none">
+            <a:spAutoFit/>
+          </a:bodyPr>
+          <a:lstStyle/>
+          <a:p>
+            <a:r>
+              <a:rPr sz="1400" b="1">
+                <a:solidFill>
+                  <a:srgbClr val="1B365D"/>
+                </a:solidFill>
+                <a:latin typeface="Calibri"/>
+              </a:rPr>
+              <a:t>Kommo</a:t>
+            </a:r>
+          </a:p>
+        </p:txBody>
+      </p:sp>
+      <p:sp>
+        <p:nvSpPr>
+          <p:cNvPr id="30" name="TextBox 29"/>
+          <p:cNvSpPr txBox="1"/>
+          <p:nvPr/>
+        </p:nvSpPr>
+        <p:spPr>
+          <a:xfrm>
+            <a:off x="4846320" y="3977639"/>
+            <a:ext cx="1828800" cy="822960"/>
+          </a:xfrm>
+          <a:prstGeom prst="rect">
+            <a:avLst/>
+          </a:prstGeom>
+          <a:noFill/>
+        </p:spPr>
+        <p:txBody>
+          <a:bodyPr wrap="square">
+            <a:spAutoFit/>
+          </a:bodyPr>
+          <a:lstStyle/>
+          <a:p>
+            <a:r>
+              <a:rPr sz="950">
+                <a:solidFill>
+                  <a:srgbClr val="2D3A4A"/>
+                </a:solidFill>
+                <a:latin typeface="Calibri"/>
+              </a:rPr>
+              <a:t>CRM + WhatsApp + IA integrado
+Ideal equipas comerciais</a:t>
+            </a:r>
+          </a:p>
+        </p:txBody>
+      </p:sp>
+      <p:sp>
+        <p:nvSpPr>
+          <p:cNvPr id="31" name="Rectangle 30"/>
+          <p:cNvSpPr/>
+          <p:nvPr/>
+        </p:nvSpPr>
+        <p:spPr>
+          <a:xfrm>
+            <a:off x="6949440" y="3429000"/>
+            <a:ext cx="2011680" cy="1417320"/>
+          </a:xfrm>
+          <a:prstGeom prst="rect">
+            <a:avLst/>
+          </a:prstGeom>
+          <a:solidFill>
+            <a:srgbClr val="FFFFFF"/>
+          </a:solidFill>
+          <a:ln>
+            <a:noFill/>
+          </a:ln>
+        </p:spPr>
+        <p:style>
+          <a:lnRef idx="1">
+            <a:schemeClr val="accent1"/>
+          </a:lnRef>
+          <a:fillRef idx="3">
+            <a:schemeClr val="accent1"/>
+          </a:fillRef>
+          <a:effectRef idx="2">
+            <a:schemeClr val="accent1"/>
+          </a:effectRef>
+          <a:fontRef idx="minor">
+            <a:schemeClr val="lt1"/>
+          </a:fontRef>
+        </p:style>
+        <p:txBody>
+          <a:bodyPr rtlCol="0" anchor="ctr"/>
+          <a:lstStyle/>
+          <a:p>
+            <a:pPr algn="ctr"/>
+          </a:p>
+        </p:txBody>
+      </p:sp>
+      <p:sp>
+        <p:nvSpPr>
+          <p:cNvPr id="32" name="Rectangle 31"/>
+          <p:cNvSpPr/>
+          <p:nvPr/>
+        </p:nvSpPr>
+        <p:spPr>
+          <a:xfrm>
+            <a:off x="6949440" y="3429000"/>
+            <a:ext cx="2011680" cy="256032"/>
+          </a:xfrm>
+          <a:prstGeom prst="rect">
+            <a:avLst/>
+          </a:prstGeom>
+          <a:solidFill>
+            <a:srgbClr val="E87722"/>
+          </a:solidFill>
+          <a:ln>
+            <a:noFill/>
+          </a:ln>
+        </p:spPr>
+        <p:style>
+          <a:lnRef idx="1">
+            <a:schemeClr val="accent1"/>
+          </a:lnRef>
+          <a:fillRef idx="3">
+            <a:schemeClr val="accent1"/>
+          </a:fillRef>
+          <a:effectRef idx="2">
+            <a:schemeClr val="accent1"/>
+          </a:effectRef>
+          <a:fontRef idx="minor">
+            <a:schemeClr val="lt1"/>
+          </a:fontRef>
+        </p:style>
+        <p:txBody>
+          <a:bodyPr rtlCol="0" anchor="ctr"/>
+          <a:lstStyle/>
+          <a:p>
+            <a:pPr algn="ctr"/>
+            <a:r>
+              <a:rPr sz="900" b="1">
+                <a:solidFill>
+                  <a:srgbClr val="FFFFFF"/>
+                </a:solidFill>
+                <a:latin typeface="Calibri"/>
+              </a:rPr>
+              <a:t>CORRER | $159/mes</a:t>
+            </a:r>
+          </a:p>
+        </p:txBody>
+      </p:sp>
+      <p:sp>
+        <p:nvSpPr>
+          <p:cNvPr id="33" name="TextBox 32"/>
+          <p:cNvSpPr txBox="1"/>
+          <p:nvPr/>
+        </p:nvSpPr>
+        <p:spPr>
+          <a:xfrm>
+            <a:off x="7040879" y="3730752"/>
+            <a:ext cx="1828800" cy="274320"/>
+          </a:xfrm>
+          <a:prstGeom prst="rect">
+            <a:avLst/>
+          </a:prstGeom>
+          <a:noFill/>
+        </p:spPr>
+        <p:txBody>
+          <a:bodyPr wrap="none">
+            <a:spAutoFit/>
+          </a:bodyPr>
+          <a:lstStyle/>
+          <a:p>
+            <a:r>
+              <a:rPr sz="1400" b="1">
+                <a:solidFill>
+                  <a:srgbClr val="1B365D"/>
+                </a:solidFill>
+                <a:latin typeface="Calibri"/>
+              </a:rPr>
+              <a:t>Respond.io</a:t>
+            </a:r>
+          </a:p>
+        </p:txBody>
+      </p:sp>
+      <p:sp>
+        <p:nvSpPr>
+          <p:cNvPr id="34" name="TextBox 33"/>
+          <p:cNvSpPr txBox="1"/>
+          <p:nvPr/>
+        </p:nvSpPr>
+        <p:spPr>
+          <a:xfrm>
+            <a:off x="7040879" y="3977639"/>
+            <a:ext cx="1828800" cy="822960"/>
+          </a:xfrm>
+          <a:prstGeom prst="rect">
+            <a:avLst/>
+          </a:prstGeom>
+          <a:noFill/>
+        </p:spPr>
+        <p:txBody>
+          <a:bodyPr wrap="square">
+            <a:spAutoFit/>
+          </a:bodyPr>
+          <a:lstStyle/>
+          <a:p>
+            <a:r>
+              <a:rPr sz="950">
+                <a:solidFill>
+                  <a:srgbClr val="2D3A4A"/>
+                </a:solidFill>
+                <a:latin typeface="Calibri"/>
+              </a:rPr>
+              <a:t>Multi-canal + AI Agents
+10+ canais | PMEs maduras</a:t>
+            </a:r>
+          </a:p>
+        </p:txBody>
+      </p:sp>
+      <p:sp>
+        <p:nvSpPr>
+          <p:cNvPr id="35" name="Rectangle 34"/>
+          <p:cNvSpPr/>
+          <p:nvPr/>
+        </p:nvSpPr>
+        <p:spPr>
+          <a:xfrm>
+            <a:off x="365760" y="4983480"/>
+            <a:ext cx="8412480" cy="411480"/>
+          </a:xfrm>
+          <a:prstGeom prst="rect">
+            <a:avLst/>
+          </a:prstGeom>
+          <a:solidFill>
+            <a:srgbClr val="1B365D"/>
+          </a:solidFill>
+          <a:ln>
+            <a:noFill/>
+          </a:ln>
+        </p:spPr>
+        <p:style>
+          <a:lnRef idx="1">
+            <a:schemeClr val="accent1"/>
+          </a:lnRef>
+          <a:fillRef idx="3">
+            <a:schemeClr val="accent1"/>
+          </a:fillRef>
+          <a:effectRef idx="2">
+            <a:schemeClr val="accent1"/>
+          </a:effectRef>
+          <a:fontRef idx="minor">
+            <a:schemeClr val="lt1"/>
+          </a:fontRef>
+        </p:style>
+        <p:txBody>
+          <a:bodyPr rtlCol="0" anchor="ctr"/>
+          <a:lstStyle/>
+          <a:p>
+            <a:pPr algn="ctr"/>
+          </a:p>
+        </p:txBody>
+      </p:sp>
+      <p:sp>
+        <p:nvSpPr>
+          <p:cNvPr id="36" name="TextBox 35"/>
+          <p:cNvSpPr txBox="1"/>
+          <p:nvPr/>
+        </p:nvSpPr>
+        <p:spPr>
+          <a:xfrm>
+            <a:off x="457200" y="5010912"/>
+            <a:ext cx="8229600" cy="365760"/>
+          </a:xfrm>
+          <a:prstGeom prst="rect">
+            <a:avLst/>
+          </a:prstGeom>
+          <a:noFill/>
+        </p:spPr>
+        <p:txBody>
+          <a:bodyPr wrap="square">
+            <a:spAutoFit/>
+          </a:bodyPr>
+          <a:lstStyle/>
+          <a:p>
+            <a:pPr algn="ctr"/>
+            <a:r>
+              <a:rPr sz="1200" b="1">
+                <a:solidFill>
+                  <a:srgbClr val="FFFFFF"/>
+                </a:solidFill>
+                <a:latin typeface="Calibri"/>
+              </a:rPr>
+              <a:t>Comece Tidio (E0) &gt; Valide WATI ($59) &gt; Escale Kommo/Respond.io</a:t>
+            </a:r>
+          </a:p>
+        </p:txBody>
+      </p:sp>
+    </p:spTree>
+  </p:cSld>
+  <p:clrMapOvr>
+    <a:masterClrMapping/>
+  </p:clrMapOvr>
+</p:sld>
+</file>
+
 <file path=ppt/slides/slide5.xml><?xml version="1.0" encoding="utf-8"?>
 <p:sld xmlns:a="http://schemas.openxmlformats.org/drawingml/2006/main" xmlns:r="http://schemas.openxmlformats.org/officeDocument/2006/relationships" xmlns:p="http://schemas.openxmlformats.org/presentationml/2006/main">
   <p:cSld name="Slide 5">

</xml_diff>